<commit_message>
Fix flowchart: add vertical distribution line, fix arrow paths, clean labels
</commit_message>
<xml_diff>
--- a/TechTrack_Presentation.pptx
+++ b/TechTrack_Presentation.pptx
@@ -12192,10 +12192,6 @@
             <a:r>
               <a:t>Show Error</a:t>
             </a:r>
-            <a:br/>
-            <a:r>
-              <a:t>Message</a:t>
-            </a:r>
           </a:p>
         </p:txBody>
       </p:sp>
@@ -12217,7 +12213,6 @@
             <a:solidFill>
               <a:srgbClr val="DC3C32"/>
             </a:solidFill>
-            <a:tailEnd type="triangle" w="med" len="med"/>
           </a:ln>
         </p:spPr>
         <p:style>
@@ -12818,7 +12813,7 @@
         <p:spPr>
           <a:xfrm>
             <a:off x="6309360" y="1563624.0"/>
-            <a:ext cx="548640.0" cy="0.0"/>
+            <a:ext cx="0" cy="3803904.0"/>
           </a:xfrm>
           <a:prstGeom prst="line">
             <a:avLst/>
@@ -12827,7 +12822,6 @@
             <a:solidFill>
               <a:srgbClr val="788291"/>
             </a:solidFill>
-            <a:tailEnd type="triangle" w="med" len="med"/>
           </a:ln>
         </p:spPr>
         <p:style>
@@ -12853,7 +12847,7 @@
         </p:nvCxnSpPr>
         <p:spPr>
           <a:xfrm>
-            <a:off x="6309360" y="2093976.0"/>
+            <a:off x="6309360" y="1563624.0"/>
             <a:ext cx="548640.0" cy="0.0"/>
           </a:xfrm>
           <a:prstGeom prst="line">
@@ -12889,7 +12883,7 @@
         </p:nvCxnSpPr>
         <p:spPr>
           <a:xfrm>
-            <a:off x="6309360" y="2624328.0"/>
+            <a:off x="6309360" y="2093976.0"/>
             <a:ext cx="548640.0" cy="0.0"/>
           </a:xfrm>
           <a:prstGeom prst="line">
@@ -12925,7 +12919,7 @@
         </p:nvCxnSpPr>
         <p:spPr>
           <a:xfrm>
-            <a:off x="6309360" y="3154680.0"/>
+            <a:off x="6309360" y="2624328.0"/>
             <a:ext cx="548640.0" cy="0.0"/>
           </a:xfrm>
           <a:prstGeom prst="line">
@@ -12961,7 +12955,7 @@
         </p:nvCxnSpPr>
         <p:spPr>
           <a:xfrm>
-            <a:off x="6309360" y="3685032.0"/>
+            <a:off x="6309360" y="3154680.0"/>
             <a:ext cx="548640.0" cy="0.0"/>
           </a:xfrm>
           <a:prstGeom prst="line">
@@ -12989,9 +12983,45 @@
           </a:fontRef>
         </p:style>
       </p:cxnSp>
-      <p:sp>
-        <p:nvSpPr>
-          <p:cNvPr id="35" name="Rounded Rectangle 34"/>
+      <p:cxnSp>
+        <p:nvCxnSpPr>
+          <p:cNvPr id="35" name="Connector 34"/>
+          <p:cNvCxnSpPr/>
+          <p:nvPr/>
+        </p:nvCxnSpPr>
+        <p:spPr>
+          <a:xfrm>
+            <a:off x="6309360" y="3685032.0"/>
+            <a:ext cx="548640.0" cy="0.0"/>
+          </a:xfrm>
+          <a:prstGeom prst="line">
+            <a:avLst/>
+          </a:prstGeom>
+          <a:ln w="15240">
+            <a:solidFill>
+              <a:srgbClr val="788291"/>
+            </a:solidFill>
+            <a:tailEnd type="triangle" w="med" len="med"/>
+          </a:ln>
+        </p:spPr>
+        <p:style>
+          <a:lnRef idx="2">
+            <a:schemeClr val="accent1"/>
+          </a:lnRef>
+          <a:fillRef idx="0">
+            <a:schemeClr val="accent1"/>
+          </a:fillRef>
+          <a:effectRef idx="1">
+            <a:schemeClr val="accent1"/>
+          </a:effectRef>
+          <a:fontRef idx="minor">
+            <a:schemeClr val="tx1"/>
+          </a:fontRef>
+        </p:style>
+      </p:cxnSp>
+      <p:sp>
+        <p:nvSpPr>
+          <p:cNvPr id="36" name="Rounded Rectangle 35"/>
           <p:cNvSpPr/>
           <p:nvPr/>
         </p:nvSpPr>
@@ -13036,7 +13066,7 @@
       </p:sp>
       <p:sp>
         <p:nvSpPr>
-          <p:cNvPr id="36" name="Rectangle 35"/>
+          <p:cNvPr id="37" name="Rectangle 36"/>
           <p:cNvSpPr/>
           <p:nvPr/>
         </p:nvSpPr>
@@ -13079,7 +13109,7 @@
       </p:sp>
       <p:sp>
         <p:nvSpPr>
-          <p:cNvPr id="37" name="TextBox 36"/>
+          <p:cNvPr id="38" name="TextBox 37"/>
           <p:cNvSpPr txBox="1"/>
           <p:nvPr/>
         </p:nvSpPr>
@@ -13112,7 +13142,7 @@
       </p:sp>
       <p:sp>
         <p:nvSpPr>
-          <p:cNvPr id="38" name="Rounded Rectangle 37"/>
+          <p:cNvPr id="39" name="Rounded Rectangle 38"/>
           <p:cNvSpPr/>
           <p:nvPr/>
         </p:nvSpPr>
@@ -13164,7 +13194,7 @@
       </p:sp>
       <p:sp>
         <p:nvSpPr>
-          <p:cNvPr id="39" name="Rounded Rectangle 38"/>
+          <p:cNvPr id="40" name="Rounded Rectangle 39"/>
           <p:cNvSpPr/>
           <p:nvPr/>
         </p:nvSpPr>
@@ -13216,7 +13246,7 @@
       </p:sp>
       <p:sp>
         <p:nvSpPr>
-          <p:cNvPr id="40" name="Rounded Rectangle 39"/>
+          <p:cNvPr id="41" name="Rounded Rectangle 40"/>
           <p:cNvSpPr/>
           <p:nvPr/>
         </p:nvSpPr>
@@ -13268,7 +13298,7 @@
       </p:sp>
       <p:sp>
         <p:nvSpPr>
-          <p:cNvPr id="41" name="Rounded Rectangle 40"/>
+          <p:cNvPr id="42" name="Rounded Rectangle 41"/>
           <p:cNvSpPr/>
           <p:nvPr/>
         </p:nvSpPr>
@@ -13320,7 +13350,7 @@
       </p:sp>
       <p:sp>
         <p:nvSpPr>
-          <p:cNvPr id="42" name="Rounded Rectangle 41"/>
+          <p:cNvPr id="43" name="Rounded Rectangle 42"/>
           <p:cNvSpPr/>
           <p:nvPr/>
         </p:nvSpPr>
@@ -13372,7 +13402,7 @@
       </p:sp>
       <p:cxnSp>
         <p:nvCxnSpPr>
-          <p:cNvPr id="43" name="Connector 42"/>
+          <p:cNvPr id="44" name="Connector 43"/>
           <p:cNvCxnSpPr/>
           <p:nvPr/>
         </p:nvCxnSpPr>
@@ -13408,7 +13438,7 @@
       </p:cxnSp>
       <p:sp>
         <p:nvSpPr>
-          <p:cNvPr id="44" name="TextBox 43"/>
+          <p:cNvPr id="45" name="TextBox 44"/>
           <p:cNvSpPr txBox="1"/>
           <p:nvPr/>
         </p:nvSpPr>
@@ -13441,7 +13471,7 @@
       </p:sp>
       <p:sp>
         <p:nvSpPr>
-          <p:cNvPr id="45" name="TextBox 44"/>
+          <p:cNvPr id="46" name="TextBox 45"/>
           <p:cNvSpPr txBox="1"/>
           <p:nvPr/>
         </p:nvSpPr>
@@ -13474,7 +13504,7 @@
       </p:sp>
       <p:cxnSp>
         <p:nvCxnSpPr>
-          <p:cNvPr id="46" name="Connector 45"/>
+          <p:cNvPr id="47" name="Connector 46"/>
           <p:cNvCxnSpPr/>
           <p:nvPr/>
         </p:nvCxnSpPr>
@@ -13490,43 +13520,6 @@
             <a:solidFill>
               <a:srgbClr val="DC3C32"/>
             </a:solidFill>
-            <a:tailEnd type="triangle" w="med" len="med"/>
-          </a:ln>
-        </p:spPr>
-        <p:style>
-          <a:lnRef idx="2">
-            <a:schemeClr val="accent1"/>
-          </a:lnRef>
-          <a:fillRef idx="0">
-            <a:schemeClr val="accent1"/>
-          </a:fillRef>
-          <a:effectRef idx="1">
-            <a:schemeClr val="accent1"/>
-          </a:effectRef>
-          <a:fontRef idx="minor">
-            <a:schemeClr val="tx1"/>
-          </a:fontRef>
-        </p:style>
-      </p:cxnSp>
-      <p:cxnSp>
-        <p:nvCxnSpPr>
-          <p:cNvPr id="47" name="Connector 46"/>
-          <p:cNvCxnSpPr/>
-          <p:nvPr/>
-        </p:nvCxnSpPr>
-        <p:spPr>
-          <a:xfrm flipV="1">
-            <a:off x="1097280" y="2194560"/>
-            <a:ext cx="0" cy="3172968"/>
-          </a:xfrm>
-          <a:prstGeom prst="line">
-            <a:avLst/>
-          </a:prstGeom>
-          <a:ln w="25400">
-            <a:solidFill>
-              <a:srgbClr val="DC3C32"/>
-            </a:solidFill>
-            <a:tailEnd type="triangle" w="med" len="med"/>
           </a:ln>
         </p:spPr>
         <p:style>
@@ -13547,6 +13540,41 @@
       <p:cxnSp>
         <p:nvCxnSpPr>
           <p:cNvPr id="48" name="Connector 47"/>
+          <p:cNvCxnSpPr/>
+          <p:nvPr/>
+        </p:nvCxnSpPr>
+        <p:spPr>
+          <a:xfrm flipV="1">
+            <a:off x="1097280" y="2194560"/>
+            <a:ext cx="0" cy="3172968"/>
+          </a:xfrm>
+          <a:prstGeom prst="line">
+            <a:avLst/>
+          </a:prstGeom>
+          <a:ln w="25400">
+            <a:solidFill>
+              <a:srgbClr val="DC3C32"/>
+            </a:solidFill>
+          </a:ln>
+        </p:spPr>
+        <p:style>
+          <a:lnRef idx="2">
+            <a:schemeClr val="accent1"/>
+          </a:lnRef>
+          <a:fillRef idx="0">
+            <a:schemeClr val="accent1"/>
+          </a:fillRef>
+          <a:effectRef idx="1">
+            <a:schemeClr val="accent1"/>
+          </a:effectRef>
+          <a:fontRef idx="minor">
+            <a:schemeClr val="tx1"/>
+          </a:fontRef>
+        </p:style>
+      </p:cxnSp>
+      <p:cxnSp>
+        <p:nvCxnSpPr>
+          <p:cNvPr id="49" name="Connector 48"/>
           <p:cNvCxnSpPr/>
           <p:nvPr/>
         </p:nvCxnSpPr>

</xml_diff>